<commit_message>
remove old figs and update
</commit_message>
<xml_diff>
--- a/figs/fig1.pptx
+++ b/figs/fig1.pptx
@@ -260,7 +260,7 @@
           <a:p>
             <a:fld id="{BFBBBFAB-639F-4F44-8AC5-62BA21F76FBF}" type="datetimeFigureOut">
               <a:rPr lang="en-US" smtClean="0"/>
-              <a:t>8/8/2025</a:t>
+              <a:t>3/6/2026</a:t>
             </a:fld>
             <a:endParaRPr lang="en-US"/>
           </a:p>
@@ -458,7 +458,7 @@
           <a:p>
             <a:fld id="{BFBBBFAB-639F-4F44-8AC5-62BA21F76FBF}" type="datetimeFigureOut">
               <a:rPr lang="en-US" smtClean="0"/>
-              <a:t>8/8/2025</a:t>
+              <a:t>3/6/2026</a:t>
             </a:fld>
             <a:endParaRPr lang="en-US"/>
           </a:p>
@@ -666,7 +666,7 @@
           <a:p>
             <a:fld id="{BFBBBFAB-639F-4F44-8AC5-62BA21F76FBF}" type="datetimeFigureOut">
               <a:rPr lang="en-US" smtClean="0"/>
-              <a:t>8/8/2025</a:t>
+              <a:t>3/6/2026</a:t>
             </a:fld>
             <a:endParaRPr lang="en-US"/>
           </a:p>
@@ -864,7 +864,7 @@
           <a:p>
             <a:fld id="{BFBBBFAB-639F-4F44-8AC5-62BA21F76FBF}" type="datetimeFigureOut">
               <a:rPr lang="en-US" smtClean="0"/>
-              <a:t>8/8/2025</a:t>
+              <a:t>3/6/2026</a:t>
             </a:fld>
             <a:endParaRPr lang="en-US"/>
           </a:p>
@@ -1139,7 +1139,7 @@
           <a:p>
             <a:fld id="{BFBBBFAB-639F-4F44-8AC5-62BA21F76FBF}" type="datetimeFigureOut">
               <a:rPr lang="en-US" smtClean="0"/>
-              <a:t>8/8/2025</a:t>
+              <a:t>3/6/2026</a:t>
             </a:fld>
             <a:endParaRPr lang="en-US"/>
           </a:p>
@@ -1404,7 +1404,7 @@
           <a:p>
             <a:fld id="{BFBBBFAB-639F-4F44-8AC5-62BA21F76FBF}" type="datetimeFigureOut">
               <a:rPr lang="en-US" smtClean="0"/>
-              <a:t>8/8/2025</a:t>
+              <a:t>3/6/2026</a:t>
             </a:fld>
             <a:endParaRPr lang="en-US"/>
           </a:p>
@@ -1816,7 +1816,7 @@
           <a:p>
             <a:fld id="{BFBBBFAB-639F-4F44-8AC5-62BA21F76FBF}" type="datetimeFigureOut">
               <a:rPr lang="en-US" smtClean="0"/>
-              <a:t>8/8/2025</a:t>
+              <a:t>3/6/2026</a:t>
             </a:fld>
             <a:endParaRPr lang="en-US"/>
           </a:p>
@@ -1957,7 +1957,7 @@
           <a:p>
             <a:fld id="{BFBBBFAB-639F-4F44-8AC5-62BA21F76FBF}" type="datetimeFigureOut">
               <a:rPr lang="en-US" smtClean="0"/>
-              <a:t>8/8/2025</a:t>
+              <a:t>3/6/2026</a:t>
             </a:fld>
             <a:endParaRPr lang="en-US"/>
           </a:p>
@@ -2070,7 +2070,7 @@
           <a:p>
             <a:fld id="{BFBBBFAB-639F-4F44-8AC5-62BA21F76FBF}" type="datetimeFigureOut">
               <a:rPr lang="en-US" smtClean="0"/>
-              <a:t>8/8/2025</a:t>
+              <a:t>3/6/2026</a:t>
             </a:fld>
             <a:endParaRPr lang="en-US"/>
           </a:p>
@@ -2381,7 +2381,7 @@
           <a:p>
             <a:fld id="{BFBBBFAB-639F-4F44-8AC5-62BA21F76FBF}" type="datetimeFigureOut">
               <a:rPr lang="en-US" smtClean="0"/>
-              <a:t>8/8/2025</a:t>
+              <a:t>3/6/2026</a:t>
             </a:fld>
             <a:endParaRPr lang="en-US"/>
           </a:p>
@@ -2669,7 +2669,7 @@
           <a:p>
             <a:fld id="{BFBBBFAB-639F-4F44-8AC5-62BA21F76FBF}" type="datetimeFigureOut">
               <a:rPr lang="en-US" smtClean="0"/>
-              <a:t>8/8/2025</a:t>
+              <a:t>3/6/2026</a:t>
             </a:fld>
             <a:endParaRPr lang="en-US"/>
           </a:p>
@@ -2910,7 +2910,7 @@
           <a:p>
             <a:fld id="{BFBBBFAB-639F-4F44-8AC5-62BA21F76FBF}" type="datetimeFigureOut">
               <a:rPr lang="en-US" smtClean="0"/>
-              <a:t>8/8/2025</a:t>
+              <a:t>3/6/2026</a:t>
             </a:fld>
             <a:endParaRPr lang="en-US"/>
           </a:p>
@@ -24430,7 +24430,7 @@
         <p:spPr>
           <a:xfrm>
             <a:off x="7643476" y="1137267"/>
-            <a:ext cx="5125757" cy="461665"/>
+            <a:ext cx="5125757" cy="830997"/>
           </a:xfrm>
           <a:prstGeom prst="rect">
             <a:avLst/>
@@ -24446,7 +24446,14 @@
             <a:pPr algn="ctr"/>
             <a:r>
               <a:rPr lang="en-US" sz="2400" dirty="0"/>
-              <a:t>Export</a:t>
+              <a:t>Export </a:t>
+            </a:r>
+          </a:p>
+          <a:p>
+            <a:pPr algn="ctr"/>
+            <a:r>
+              <a:rPr lang="en-US" sz="2400" dirty="0"/>
+              <a:t>(for MPA analysis)</a:t>
             </a:r>
           </a:p>
         </p:txBody>
@@ -24766,7 +24773,7 @@
             <a:pPr algn="ctr"/>
             <a:r>
               <a:rPr lang="en-US" sz="2400" b="1" dirty="0"/>
-              <a:t>MPA </a:t>
+              <a:t>Patch </a:t>
             </a:r>
             <a:r>
               <a:rPr lang="en-US" sz="2400" b="1" i="1" dirty="0"/>
@@ -24882,7 +24889,7 @@
             <a:pPr algn="ctr"/>
             <a:r>
               <a:rPr lang="en-US" sz="2400" dirty="0"/>
-              <a:t>MPA </a:t>
+              <a:t>Patch </a:t>
             </a:r>
             <a:r>
               <a:rPr lang="en-US" sz="2400" i="1" dirty="0"/>
@@ -24941,7 +24948,7 @@
             <a:pPr algn="ctr"/>
             <a:r>
               <a:rPr lang="en-US" sz="2400" b="1" dirty="0"/>
-              <a:t>MPA </a:t>
+              <a:t>Patch </a:t>
             </a:r>
             <a:r>
               <a:rPr lang="en-US" sz="2400" b="1" i="1" dirty="0"/>
@@ -25037,8 +25044,12 @@
           <a:p>
             <a:pPr algn="ctr"/>
             <a:r>
+              <a:rPr lang="en-US" sz="2400"/>
+              <a:t>Overall Connectivity </a:t>
+            </a:r>
+            <a:r>
               <a:rPr lang="en-US" sz="2400" dirty="0"/>
-              <a:t>MPA Origin Settlers = Retention + Import</a:t>
+              <a:t>= Retention + Import</a:t>
             </a:r>
           </a:p>
         </p:txBody>

</xml_diff>